<commit_message>
Match the brief's two-endpoint contract: sync /generate + drop custom-template CRUD
- POST /generate is now synchronous: returns the ArticleJSON (200), the brief's contract (one POST to upload, one POST to generate -> JSON). ?async=true keeps the 202 + poll path for long/bursty jobs; GET /generate/{pair}/{job} is optional. Idempotency-Key reuses the same result.
- Removed custom-template CRUD (GET/POST/PUT/DELETE /templates) + store methods; the 4 built-in layouts remain (selected via template_id), UI lists them statically.
- UI uses the sync response (no polling); deploy.sh --timeout 600 for the blocking model call.
- Synced README, ARCHITECTURE, openapi.json, Postman (trimmed to the brief flow); deck updated to the sync contract. 47 tests passing.
</commit_message>
<xml_diff>
--- a/Case2_GenAI_Collateral.pptx
+++ b/Case2_GenAI_Collateral.pptx
@@ -15,6 +15,7 @@
     <p:sldId id="263" r:id="rId14"/>
     <p:sldId id="264" r:id="rId15"/>
     <p:sldId id="265" r:id="rId16"/>
+    <p:sldId id="266" r:id="rId17"/>
   </p:sldIdLst>
   <p:sldSz cx="12191695" cy="6858000" type="screen4x3"/>
   <p:notesSz cx="6858000" cy="9144000"/>
@@ -3435,7 +3436,7 @@
                 </a:solidFill>
                 <a:latin typeface="Consolas"/>
               </a:rPr>
-              <a:t>ROADMAP</a:t>
+              <a:t>DESIGN DECISIONS</a:t>
             </a:r>
           </a:p>
         </p:txBody>
@@ -3474,21 +3475,56 @@
                 </a:solidFill>
                 <a:latin typeface="Trebuchet MS"/>
               </a:rPr>
-              <a:t>A working slice today — a clear path to scale</a:t>
-            </a:r>
-          </a:p>
-        </p:txBody>
-      </p:sp>
-      <p:sp>
-        <p:nvSpPr>
-          <p:cNvPr id="4" name="Rounded Rectangle 3"/>
+              <a:t>Why these choices?</a:t>
+            </a:r>
+          </a:p>
+        </p:txBody>
+      </p:sp>
+      <p:sp>
+        <p:nvSpPr>
+          <p:cNvPr id="4" name="TextBox 3"/>
+          <p:cNvSpPr txBox="1"/>
+          <p:nvPr/>
+        </p:nvSpPr>
+        <p:spPr>
+          <a:xfrm>
+            <a:off x="777240" y="1572768"/>
+            <a:ext cx="10607040" cy="365760"/>
+          </a:xfrm>
+          <a:prstGeom prst="rect">
+            <a:avLst/>
+          </a:prstGeom>
+          <a:noFill/>
+        </p:spPr>
+        <p:txBody>
+          <a:bodyPr wrap="square" anchor="t" lIns="0" rIns="0" tIns="0" bIns="0">
+            <a:spAutoFit/>
+          </a:bodyPr>
+          <a:lstStyle/>
+          <a:p>
+            <a:pPr algn="l"/>
+            <a:r>
+              <a:rPr sz="1400" b="0">
+                <a:solidFill>
+                  <a:srgbClr val="475569"/>
+                </a:solidFill>
+                <a:latin typeface="Calibri"/>
+              </a:rPr>
+              <a:t>Pragmatism over shiny — the simplest thing that works, with the upgrade path named.</a:t>
+            </a:r>
+          </a:p>
+        </p:txBody>
+      </p:sp>
+      <p:sp>
+        <p:nvSpPr>
+          <p:cNvPr id="5" name="Rounded Rectangle 4"/>
           <p:cNvSpPr/>
           <p:nvPr/>
         </p:nvSpPr>
         <p:spPr>
           <a:xfrm>
-            <a:off x="777240" y="2240280"/>
-            <a:ext cx="5212080" cy="1691640"/>
+            <a:off x="777240" y="2148840"/>
+            <a:ext cx="10607040" cy="731520"/>
           </a:xfrm>
           <a:prstGeom prst="roundRect">
             <a:avLst/>
@@ -3536,14 +3572,14 @@
       </p:sp>
       <p:sp>
         <p:nvSpPr>
-          <p:cNvPr id="5" name="TextBox 4"/>
+          <p:cNvPr id="6" name="TextBox 5"/>
           <p:cNvSpPr txBox="1"/>
           <p:nvPr/>
         </p:nvSpPr>
         <p:spPr>
           <a:xfrm>
-            <a:off x="1051560" y="2468880"/>
-            <a:ext cx="4663440" cy="457200"/>
+            <a:off x="1051560" y="2258568"/>
+            <a:ext cx="10058400" cy="292608"/>
           </a:xfrm>
           <a:prstGeom prst="rect">
             <a:avLst/>
@@ -3558,27 +3594,27 @@
           <a:p>
             <a:pPr algn="l"/>
             <a:r>
-              <a:rPr sz="1500" b="1">
+              <a:rPr sz="1400" b="1">
                 <a:solidFill>
                   <a:srgbClr val="10151E"/>
                 </a:solidFill>
                 <a:latin typeface="Trebuchet MS"/>
               </a:rPr>
-              <a:t>Multi-tenancy</a:t>
-            </a:r>
-          </a:p>
-        </p:txBody>
-      </p:sp>
-      <p:sp>
-        <p:nvSpPr>
-          <p:cNvPr id="6" name="TextBox 5"/>
+              <a:t>Deterministic typed pipeline — not an agent</a:t>
+            </a:r>
+          </a:p>
+        </p:txBody>
+      </p:sp>
+      <p:sp>
+        <p:nvSpPr>
+          <p:cNvPr id="7" name="TextBox 6"/>
           <p:cNvSpPr txBox="1"/>
           <p:nvPr/>
         </p:nvSpPr>
         <p:spPr>
           <a:xfrm>
-            <a:off x="1051560" y="3017520"/>
-            <a:ext cx="4663440" cy="822960"/>
+            <a:off x="1051560" y="2569464"/>
+            <a:ext cx="10058400" cy="274320"/>
           </a:xfrm>
           <a:prstGeom prst="rect">
             <a:avLst/>
@@ -3591,33 +3627,29 @@
           </a:bodyPr>
           <a:lstStyle/>
           <a:p>
-            <a:pPr algn="l">
-              <a:lnSpc>
-                <a:spcPct val="115000"/>
-              </a:lnSpc>
-            </a:pPr>
-            <a:r>
-              <a:rPr sz="1300" b="0">
+            <a:pPr algn="l"/>
+            <a:r>
+              <a:rPr sz="1150" b="0">
                 <a:solidFill>
                   <a:srgbClr val="475569"/>
                 </a:solidFill>
                 <a:latin typeface="Calibri"/>
               </a:rPr>
-              <a:t>tenant from the token; per-tenant CMEK + budgets (plumbing already in place)</a:t>
-            </a:r>
-          </a:p>
-        </p:txBody>
-      </p:sp>
-      <p:sp>
-        <p:nvSpPr>
-          <p:cNvPr id="7" name="Rounded Rectangle 6"/>
+              <a:t>predictable, testable, traceable; ADK / Agent Engine only when we add tools or a HITL pause</a:t>
+            </a:r>
+          </a:p>
+        </p:txBody>
+      </p:sp>
+      <p:sp>
+        <p:nvSpPr>
+          <p:cNvPr id="8" name="Rounded Rectangle 7"/>
           <p:cNvSpPr/>
           <p:nvPr/>
         </p:nvSpPr>
         <p:spPr>
           <a:xfrm>
-            <a:off x="6172200" y="2240280"/>
-            <a:ext cx="5212080" cy="1691640"/>
+            <a:off x="777240" y="2971800"/>
+            <a:ext cx="10607040" cy="731520"/>
           </a:xfrm>
           <a:prstGeom prst="roundRect">
             <a:avLst/>
@@ -3665,14 +3697,14 @@
       </p:sp>
       <p:sp>
         <p:nvSpPr>
-          <p:cNvPr id="8" name="TextBox 7"/>
+          <p:cNvPr id="9" name="TextBox 8"/>
           <p:cNvSpPr txBox="1"/>
           <p:nvPr/>
         </p:nvSpPr>
         <p:spPr>
           <a:xfrm>
-            <a:off x="6446520" y="2468880"/>
-            <a:ext cx="4663440" cy="457200"/>
+            <a:off x="1051560" y="3081528"/>
+            <a:ext cx="10058400" cy="292608"/>
           </a:xfrm>
           <a:prstGeom prst="rect">
             <a:avLst/>
@@ -3687,27 +3719,27 @@
           <a:p>
             <a:pPr algn="l"/>
             <a:r>
-              <a:rPr sz="1500" b="1">
+              <a:rPr sz="1400" b="1">
                 <a:solidFill>
                   <a:srgbClr val="10151E"/>
                 </a:solidFill>
                 <a:latin typeface="Trebuchet MS"/>
               </a:rPr>
-              <a:t>Org dashboard</a:t>
-            </a:r>
-          </a:p>
-        </p:txBody>
-      </p:sp>
-      <p:sp>
-        <p:nvSpPr>
-          <p:cNvPr id="9" name="TextBox 8"/>
+              <a:t>Long-context grounding — not RAG</a:t>
+            </a:r>
+          </a:p>
+        </p:txBody>
+      </p:sp>
+      <p:sp>
+        <p:nvSpPr>
+          <p:cNvPr id="10" name="TextBox 9"/>
           <p:cNvSpPr txBox="1"/>
           <p:nvPr/>
         </p:nvSpPr>
         <p:spPr>
           <a:xfrm>
-            <a:off x="6446520" y="3017520"/>
-            <a:ext cx="4663440" cy="822960"/>
+            <a:off x="1051560" y="3392424"/>
+            <a:ext cx="10058400" cy="274320"/>
           </a:xfrm>
           <a:prstGeom prst="rect">
             <a:avLst/>
@@ -3720,33 +3752,29 @@
           </a:bodyPr>
           <a:lstStyle/>
           <a:p>
-            <a:pPr algn="l">
-              <a:lnSpc>
-                <a:spcPct val="115000"/>
-              </a:lnSpc>
-            </a:pPr>
-            <a:r>
-              <a:rPr sz="1300" b="0">
+            <a:pPr algn="l"/>
+            <a:r>
+              <a:rPr sz="1150" b="0">
                 <a:solidFill>
                   <a:srgbClr val="475569"/>
                 </a:solidFill>
                 <a:latin typeface="Calibri"/>
               </a:rPr>
-              <a:t>every generation → BigQuery → Looker: cost/brochure, groundedness, throughput</a:t>
-            </a:r>
-          </a:p>
-        </p:txBody>
-      </p:sp>
-      <p:sp>
-        <p:nvSpPr>
-          <p:cNvPr id="10" name="Rounded Rectangle 9"/>
+              <a:t>a bounded two-company corpus fits in context — full traceability, no vector DB; RAG when it grows</a:t>
+            </a:r>
+          </a:p>
+        </p:txBody>
+      </p:sp>
+      <p:sp>
+        <p:nvSpPr>
+          <p:cNvPr id="11" name="Rounded Rectangle 10"/>
           <p:cNvSpPr/>
           <p:nvPr/>
         </p:nvSpPr>
         <p:spPr>
           <a:xfrm>
-            <a:off x="777240" y="4160520"/>
-            <a:ext cx="5212080" cy="1691640"/>
+            <a:off x="777240" y="3794760"/>
+            <a:ext cx="10607040" cy="731520"/>
           </a:xfrm>
           <a:prstGeom prst="roundRect">
             <a:avLst/>
@@ -3794,14 +3822,14 @@
       </p:sp>
       <p:sp>
         <p:nvSpPr>
-          <p:cNvPr id="11" name="TextBox 10"/>
+          <p:cNvPr id="12" name="TextBox 11"/>
           <p:cNvSpPr txBox="1"/>
           <p:nvPr/>
         </p:nvSpPr>
         <p:spPr>
           <a:xfrm>
-            <a:off x="1051560" y="4389120"/>
-            <a:ext cx="4663440" cy="457200"/>
+            <a:off x="1051560" y="3904488"/>
+            <a:ext cx="10058400" cy="292608"/>
           </a:xfrm>
           <a:prstGeom prst="rect">
             <a:avLst/>
@@ -3816,27 +3844,27 @@
           <a:p>
             <a:pPr algn="l"/>
             <a:r>
-              <a:rPr sz="1500" b="1">
+              <a:rPr sz="1400" b="1">
                 <a:solidFill>
                   <a:srgbClr val="10151E"/>
                 </a:solidFill>
                 <a:latin typeface="Trebuchet MS"/>
               </a:rPr>
-              <a:t>Go agentic → Agent Engine</a:t>
-            </a:r>
-          </a:p>
-        </p:txBody>
-      </p:sp>
-      <p:sp>
-        <p:nvSpPr>
-          <p:cNvPr id="12" name="TextBox 11"/>
+              <a:t>Managed Gemini on Vertex — not self-hosted</a:t>
+            </a:r>
+          </a:p>
+        </p:txBody>
+      </p:sp>
+      <p:sp>
+        <p:nvSpPr>
+          <p:cNvPr id="13" name="TextBox 12"/>
           <p:cNvSpPr txBox="1"/>
           <p:nvPr/>
         </p:nvSpPr>
         <p:spPr>
           <a:xfrm>
-            <a:off x="1051560" y="4937759"/>
-            <a:ext cx="4663440" cy="822960"/>
+            <a:off x="1051560" y="4215384"/>
+            <a:ext cx="10058400" cy="274320"/>
           </a:xfrm>
           <a:prstGeom prst="rect">
             <a:avLst/>
@@ -3849,33 +3877,29 @@
           </a:bodyPr>
           <a:lstStyle/>
           <a:p>
-            <a:pPr algn="l">
-              <a:lnSpc>
-                <a:spcPct val="115000"/>
-              </a:lnSpc>
-            </a:pPr>
-            <a:r>
-              <a:rPr sz="1300" b="0">
+            <a:pPr algn="l"/>
+            <a:r>
+              <a:rPr sz="1150" b="0">
                 <a:solidFill>
                   <a:srgbClr val="475569"/>
                 </a:solidFill>
                 <a:latin typeface="Calibri"/>
               </a:rPr>
-              <a:t>when we add tools (live research, image sourcing) or a HITL pause</a:t>
-            </a:r>
-          </a:p>
-        </p:txBody>
-      </p:sp>
-      <p:sp>
-        <p:nvSpPr>
-          <p:cNvPr id="13" name="Rounded Rectangle 12"/>
+              <a:t>ship now at ~$0.01 / brochure with no GPUs to run; revisit fine-tuning only at real volume</a:t>
+            </a:r>
+          </a:p>
+        </p:txBody>
+      </p:sp>
+      <p:sp>
+        <p:nvSpPr>
+          <p:cNvPr id="14" name="Rounded Rectangle 13"/>
           <p:cNvSpPr/>
           <p:nvPr/>
         </p:nvSpPr>
         <p:spPr>
           <a:xfrm>
-            <a:off x="6172200" y="4160520"/>
-            <a:ext cx="5212080" cy="1691640"/>
+            <a:off x="777240" y="4617720"/>
+            <a:ext cx="10607040" cy="731520"/>
           </a:xfrm>
           <a:prstGeom prst="roundRect">
             <a:avLst/>
@@ -3923,14 +3947,14 @@
       </p:sp>
       <p:sp>
         <p:nvSpPr>
-          <p:cNvPr id="14" name="TextBox 13"/>
+          <p:cNvPr id="15" name="TextBox 14"/>
           <p:cNvSpPr txBox="1"/>
           <p:nvPr/>
         </p:nvSpPr>
         <p:spPr>
           <a:xfrm>
-            <a:off x="6446520" y="4389120"/>
-            <a:ext cx="4663440" cy="457200"/>
+            <a:off x="1051560" y="4727448"/>
+            <a:ext cx="10058400" cy="292608"/>
           </a:xfrm>
           <a:prstGeom prst="rect">
             <a:avLst/>
@@ -3945,27 +3969,27 @@
           <a:p>
             <a:pPr algn="l"/>
             <a:r>
-              <a:rPr sz="1500" b="1">
+              <a:rPr sz="1400" b="1">
                 <a:solidFill>
                   <a:srgbClr val="10151E"/>
                 </a:solidFill>
                 <a:latin typeface="Trebuchet MS"/>
               </a:rPr>
-              <a:t>Harden</a:t>
-            </a:r>
-          </a:p>
-        </p:txBody>
-      </p:sp>
-      <p:sp>
-        <p:nvSpPr>
-          <p:cNvPr id="15" name="TextBox 14"/>
+              <a:t>Limits &amp; images enforced in code — not the model</a:t>
+            </a:r>
+          </a:p>
+        </p:txBody>
+      </p:sp>
+      <p:sp>
+        <p:nvSpPr>
+          <p:cNvPr id="16" name="TextBox 15"/>
           <p:cNvSpPr txBox="1"/>
           <p:nvPr/>
         </p:nvSpPr>
         <p:spPr>
           <a:xfrm>
-            <a:off x="6446520" y="4937759"/>
-            <a:ext cx="4663440" cy="822960"/>
+            <a:off x="1051560" y="5038344"/>
+            <a:ext cx="10058400" cy="274320"/>
           </a:xfrm>
           <a:prstGeom prst="rect">
             <a:avLst/>
@@ -3978,33 +4002,84 @@
           </a:bodyPr>
           <a:lstStyle/>
           <a:p>
-            <a:pPr algn="l">
-              <a:lnSpc>
-                <a:spcPct val="115000"/>
-              </a:lnSpc>
-            </a:pPr>
-            <a:r>
-              <a:rPr sz="1300" b="0">
+            <a:pPr algn="l"/>
+            <a:r>
+              <a:rPr sz="1150" b="0">
                 <a:solidFill>
                   <a:srgbClr val="475569"/>
                 </a:solidFill>
                 <a:latin typeface="Calibri"/>
               </a:rPr>
-              <a:t>EU-region model residency · tune the faithfulness judge · golden eval set in CI</a:t>
-            </a:r>
-          </a:p>
-        </p:txBody>
-      </p:sp>
-      <p:sp>
-        <p:nvSpPr>
-          <p:cNvPr id="16" name="TextBox 15"/>
+              <a:t>the LLM is great at language, weak at counting/choosing — code owns word limits, image slots, JSON</a:t>
+            </a:r>
+          </a:p>
+        </p:txBody>
+      </p:sp>
+      <p:sp>
+        <p:nvSpPr>
+          <p:cNvPr id="17" name="Rounded Rectangle 16"/>
+          <p:cNvSpPr/>
+          <p:nvPr/>
+        </p:nvSpPr>
+        <p:spPr>
+          <a:xfrm>
+            <a:off x="777240" y="5440680"/>
+            <a:ext cx="10607040" cy="731520"/>
+          </a:xfrm>
+          <a:prstGeom prst="roundRect">
+            <a:avLst/>
+          </a:prstGeom>
+          <a:solidFill>
+            <a:srgbClr val="F4F6F9"/>
+          </a:solidFill>
+          <a:ln w="12700">
+            <a:solidFill>
+              <a:srgbClr val="D7DEEA"/>
+            </a:solidFill>
+          </a:ln>
+          <a:effectLst/>
+        </p:spPr>
+        <p:style>
+          <a:lnRef idx="1">
+            <a:schemeClr val="accent1"/>
+          </a:lnRef>
+          <a:fillRef idx="3">
+            <a:schemeClr val="accent1"/>
+          </a:fillRef>
+          <a:effectRef idx="2">
+            <a:schemeClr val="accent1"/>
+          </a:effectRef>
+          <a:fontRef idx="minor">
+            <a:schemeClr val="lt1"/>
+          </a:fontRef>
+        </p:style>
+        <p:txBody>
+          <a:bodyPr rtlCol="0" anchor="ctr" wrap="square" lIns="73152" rIns="73152" tIns="36576" bIns="36576"/>
+          <a:lstStyle/>
+          <a:p>
+            <a:pPr algn="ctr"/>
+            <a:r>
+              <a:rPr sz="1200" b="1">
+                <a:solidFill>
+                  <a:srgbClr val="10151E"/>
+                </a:solidFill>
+                <a:latin typeface="Calibri"/>
+              </a:rPr>
+              <a:t/>
+            </a:r>
+          </a:p>
+        </p:txBody>
+      </p:sp>
+      <p:sp>
+        <p:nvSpPr>
+          <p:cNvPr id="18" name="TextBox 17"/>
           <p:cNvSpPr txBox="1"/>
           <p:nvPr/>
         </p:nvSpPr>
         <p:spPr>
           <a:xfrm>
-            <a:off x="777240" y="6473952"/>
-            <a:ext cx="9144000" cy="274320"/>
+            <a:off x="1051560" y="5550408"/>
+            <a:ext cx="10058400" cy="292608"/>
           </a:xfrm>
           <a:prstGeom prst="rect">
             <a:avLst/>
@@ -4019,27 +4094,27 @@
           <a:p>
             <a:pPr algn="l"/>
             <a:r>
-              <a:rPr sz="900" b="0">
-                <a:solidFill>
-                  <a:srgbClr val="64748B"/>
-                </a:solidFill>
-                <a:latin typeface="Consolas"/>
-              </a:rPr>
-              <a:t>ML6 — Senior AI Engineer Challenge  ·  Case 2 · GenAI collateral</a:t>
-            </a:r>
-          </a:p>
-        </p:txBody>
-      </p:sp>
-      <p:sp>
-        <p:nvSpPr>
-          <p:cNvPr id="17" name="TextBox 16"/>
+              <a:rPr sz="1400" b="1">
+                <a:solidFill>
+                  <a:srgbClr val="10151E"/>
+                </a:solidFill>
+                <a:latin typeface="Trebuchet MS"/>
+              </a:rPr>
+              <a:t>Cloud Run — not GKE or Agent Engine</a:t>
+            </a:r>
+          </a:p>
+        </p:txBody>
+      </p:sp>
+      <p:sp>
+        <p:nvSpPr>
+          <p:cNvPr id="19" name="TextBox 18"/>
           <p:cNvSpPr txBox="1"/>
           <p:nvPr/>
         </p:nvSpPr>
         <p:spPr>
           <a:xfrm>
-            <a:off x="11338560" y="6473952"/>
-            <a:ext cx="457200" cy="274320"/>
+            <a:off x="1051560" y="5861304"/>
+            <a:ext cx="10058400" cy="274320"/>
           </a:xfrm>
           <a:prstGeom prst="rect">
             <a:avLst/>
@@ -4052,6 +4127,76 @@
           </a:bodyPr>
           <a:lstStyle/>
           <a:p>
+            <a:pPr algn="l"/>
+            <a:r>
+              <a:rPr sz="1150" b="0">
+                <a:solidFill>
+                  <a:srgbClr val="475569"/>
+                </a:solidFill>
+                <a:latin typeface="Calibri"/>
+              </a:rPr>
+              <a:t>stateless + tool-less → scale-to-zero, a tiny blast radius and minimal ops</a:t>
+            </a:r>
+          </a:p>
+        </p:txBody>
+      </p:sp>
+      <p:sp>
+        <p:nvSpPr>
+          <p:cNvPr id="20" name="TextBox 19"/>
+          <p:cNvSpPr txBox="1"/>
+          <p:nvPr/>
+        </p:nvSpPr>
+        <p:spPr>
+          <a:xfrm>
+            <a:off x="777240" y="6473952"/>
+            <a:ext cx="9144000" cy="274320"/>
+          </a:xfrm>
+          <a:prstGeom prst="rect">
+            <a:avLst/>
+          </a:prstGeom>
+          <a:noFill/>
+        </p:spPr>
+        <p:txBody>
+          <a:bodyPr wrap="square" anchor="t" lIns="0" rIns="0" tIns="0" bIns="0">
+            <a:spAutoFit/>
+          </a:bodyPr>
+          <a:lstStyle/>
+          <a:p>
+            <a:pPr algn="l"/>
+            <a:r>
+              <a:rPr sz="900" b="0">
+                <a:solidFill>
+                  <a:srgbClr val="64748B"/>
+                </a:solidFill>
+                <a:latin typeface="Consolas"/>
+              </a:rPr>
+              <a:t>ML6 — Senior AI Engineer Challenge  ·  Case 2 · GenAI collateral</a:t>
+            </a:r>
+          </a:p>
+        </p:txBody>
+      </p:sp>
+      <p:sp>
+        <p:nvSpPr>
+          <p:cNvPr id="21" name="TextBox 20"/>
+          <p:cNvSpPr txBox="1"/>
+          <p:nvPr/>
+        </p:nvSpPr>
+        <p:spPr>
+          <a:xfrm>
+            <a:off x="11338560" y="6473952"/>
+            <a:ext cx="457200" cy="274320"/>
+          </a:xfrm>
+          <a:prstGeom prst="rect">
+            <a:avLst/>
+          </a:prstGeom>
+          <a:noFill/>
+        </p:spPr>
+        <p:txBody>
+          <a:bodyPr wrap="square" anchor="t" lIns="0" rIns="0" tIns="0" bIns="0">
+            <a:spAutoFit/>
+          </a:bodyPr>
+          <a:lstStyle/>
+          <a:p>
             <a:pPr algn="r"/>
             <a:r>
               <a:rPr sz="900" b="0">
@@ -4061,6 +4206,848 @@
                 <a:latin typeface="Consolas"/>
               </a:rPr>
               <a:t>10</a:t>
+            </a:r>
+          </a:p>
+        </p:txBody>
+      </p:sp>
+    </p:spTree>
+  </p:cSld>
+  <p:clrMapOvr>
+    <a:masterClrMapping/>
+  </p:clrMapOvr>
+</p:sld>
+</file>
+
+<file path=ppt/slides/slide11.xml><?xml version="1.0" encoding="utf-8"?>
+<p:sld xmlns:a="http://schemas.openxmlformats.org/drawingml/2006/main" xmlns:p="http://schemas.openxmlformats.org/presentationml/2006/main" xmlns:r="http://schemas.openxmlformats.org/officeDocument/2006/relationships">
+  <p:cSld>
+    <p:bg>
+      <p:bgPr>
+        <a:solidFill>
+          <a:srgbClr val="FFFFFF"/>
+        </a:solidFill>
+        <a:effectLst/>
+      </p:bgPr>
+    </p:bg>
+    <p:spTree>
+      <p:nvGrpSpPr>
+        <p:cNvPr id="1" name=""/>
+        <p:cNvGrpSpPr/>
+        <p:nvPr/>
+      </p:nvGrpSpPr>
+      <p:grpSpPr/>
+      <p:sp>
+        <p:nvSpPr>
+          <p:cNvPr id="2" name="TextBox 1"/>
+          <p:cNvSpPr txBox="1"/>
+          <p:nvPr/>
+        </p:nvSpPr>
+        <p:spPr>
+          <a:xfrm>
+            <a:off x="777240" y="502920"/>
+            <a:ext cx="10058400" cy="274320"/>
+          </a:xfrm>
+          <a:prstGeom prst="rect">
+            <a:avLst/>
+          </a:prstGeom>
+          <a:noFill/>
+        </p:spPr>
+        <p:txBody>
+          <a:bodyPr wrap="square" anchor="t" lIns="0" rIns="0" tIns="0" bIns="0">
+            <a:spAutoFit/>
+          </a:bodyPr>
+          <a:lstStyle/>
+          <a:p>
+            <a:pPr algn="l"/>
+            <a:r>
+              <a:rPr sz="1200" b="1" spc="260">
+                <a:solidFill>
+                  <a:srgbClr val="0FB5A6"/>
+                </a:solidFill>
+                <a:latin typeface="Consolas"/>
+              </a:rPr>
+              <a:t>ROADMAP &amp; TRADE-OFFS</a:t>
+            </a:r>
+          </a:p>
+        </p:txBody>
+      </p:sp>
+      <p:sp>
+        <p:nvSpPr>
+          <p:cNvPr id="3" name="TextBox 2"/>
+          <p:cNvSpPr txBox="1"/>
+          <p:nvPr/>
+        </p:nvSpPr>
+        <p:spPr>
+          <a:xfrm>
+            <a:off x="749808" y="868680"/>
+            <a:ext cx="10607040" cy="1005840"/>
+          </a:xfrm>
+          <a:prstGeom prst="rect">
+            <a:avLst/>
+          </a:prstGeom>
+          <a:noFill/>
+        </p:spPr>
+        <p:txBody>
+          <a:bodyPr wrap="square" anchor="t" lIns="0" rIns="0" tIns="0" bIns="0">
+            <a:spAutoFit/>
+          </a:bodyPr>
+          <a:lstStyle/>
+          <a:p>
+            <a:pPr algn="l">
+              <a:lnSpc>
+                <a:spcPct val="102000"/>
+              </a:lnSpc>
+            </a:pPr>
+            <a:r>
+              <a:rPr sz="3000" b="1">
+                <a:solidFill>
+                  <a:srgbClr val="10151E"/>
+                </a:solidFill>
+                <a:latin typeface="Trebuchet MS"/>
+              </a:rPr>
+              <a:t>A working slice today — a clear path to scale</a:t>
+            </a:r>
+          </a:p>
+        </p:txBody>
+      </p:sp>
+      <p:sp>
+        <p:nvSpPr>
+          <p:cNvPr id="4" name="Rounded Rectangle 3"/>
+          <p:cNvSpPr/>
+          <p:nvPr/>
+        </p:nvSpPr>
+        <p:spPr>
+          <a:xfrm>
+            <a:off x="777240" y="2148840"/>
+            <a:ext cx="5212080" cy="1828800"/>
+          </a:xfrm>
+          <a:prstGeom prst="roundRect">
+            <a:avLst/>
+          </a:prstGeom>
+          <a:solidFill>
+            <a:srgbClr val="F4F6F9"/>
+          </a:solidFill>
+          <a:ln w="12700">
+            <a:solidFill>
+              <a:srgbClr val="D7DEEA"/>
+            </a:solidFill>
+          </a:ln>
+          <a:effectLst/>
+        </p:spPr>
+        <p:style>
+          <a:lnRef idx="1">
+            <a:schemeClr val="accent1"/>
+          </a:lnRef>
+          <a:fillRef idx="3">
+            <a:schemeClr val="accent1"/>
+          </a:fillRef>
+          <a:effectRef idx="2">
+            <a:schemeClr val="accent1"/>
+          </a:effectRef>
+          <a:fontRef idx="minor">
+            <a:schemeClr val="lt1"/>
+          </a:fontRef>
+        </p:style>
+        <p:txBody>
+          <a:bodyPr rtlCol="0" anchor="ctr" wrap="square" lIns="73152" rIns="73152" tIns="36576" bIns="36576"/>
+          <a:lstStyle/>
+          <a:p>
+            <a:pPr algn="ctr"/>
+            <a:r>
+              <a:rPr sz="1200" b="1">
+                <a:solidFill>
+                  <a:srgbClr val="10151E"/>
+                </a:solidFill>
+                <a:latin typeface="Calibri"/>
+              </a:rPr>
+              <a:t/>
+            </a:r>
+          </a:p>
+        </p:txBody>
+      </p:sp>
+      <p:sp>
+        <p:nvSpPr>
+          <p:cNvPr id="5" name="TextBox 4"/>
+          <p:cNvSpPr txBox="1"/>
+          <p:nvPr/>
+        </p:nvSpPr>
+        <p:spPr>
+          <a:xfrm>
+            <a:off x="1051560" y="2331720"/>
+            <a:ext cx="4663440" cy="365760"/>
+          </a:xfrm>
+          <a:prstGeom prst="rect">
+            <a:avLst/>
+          </a:prstGeom>
+          <a:noFill/>
+        </p:spPr>
+        <p:txBody>
+          <a:bodyPr wrap="square" anchor="t" lIns="0" rIns="0" tIns="0" bIns="0">
+            <a:spAutoFit/>
+          </a:bodyPr>
+          <a:lstStyle/>
+          <a:p>
+            <a:pPr algn="l"/>
+            <a:r>
+              <a:rPr sz="1500" b="1">
+                <a:solidFill>
+                  <a:srgbClr val="10151E"/>
+                </a:solidFill>
+                <a:latin typeface="Trebuchet MS"/>
+              </a:rPr>
+              <a:t>Multi-tenancy</a:t>
+            </a:r>
+          </a:p>
+        </p:txBody>
+      </p:sp>
+      <p:sp>
+        <p:nvSpPr>
+          <p:cNvPr id="6" name="TextBox 5"/>
+          <p:cNvSpPr txBox="1"/>
+          <p:nvPr/>
+        </p:nvSpPr>
+        <p:spPr>
+          <a:xfrm>
+            <a:off x="1051560" y="2734056"/>
+            <a:ext cx="4663440" cy="640080"/>
+          </a:xfrm>
+          <a:prstGeom prst="rect">
+            <a:avLst/>
+          </a:prstGeom>
+          <a:noFill/>
+        </p:spPr>
+        <p:txBody>
+          <a:bodyPr wrap="square" anchor="t" lIns="0" rIns="0" tIns="0" bIns="0">
+            <a:spAutoFit/>
+          </a:bodyPr>
+          <a:lstStyle/>
+          <a:p>
+            <a:pPr algn="l">
+              <a:lnSpc>
+                <a:spcPct val="112000"/>
+              </a:lnSpc>
+            </a:pPr>
+            <a:r>
+              <a:rPr sz="1250" b="0">
+                <a:solidFill>
+                  <a:srgbClr val="475569"/>
+                </a:solidFill>
+                <a:latin typeface="Calibri"/>
+              </a:rPr>
+              <a:t>tenant from the token; per-tenant CMEK + budgets</a:t>
+            </a:r>
+          </a:p>
+        </p:txBody>
+      </p:sp>
+      <p:sp>
+        <p:nvSpPr>
+          <p:cNvPr id="7" name="TextBox 6"/>
+          <p:cNvSpPr txBox="1"/>
+          <p:nvPr/>
+        </p:nvSpPr>
+        <p:spPr>
+          <a:xfrm>
+            <a:off x="1051560" y="3447288"/>
+            <a:ext cx="4663440" cy="457200"/>
+          </a:xfrm>
+          <a:prstGeom prst="rect">
+            <a:avLst/>
+          </a:prstGeom>
+          <a:noFill/>
+        </p:spPr>
+        <p:txBody>
+          <a:bodyPr wrap="square" anchor="t" lIns="0" rIns="0" tIns="0" bIns="0">
+            <a:spAutoFit/>
+          </a:bodyPr>
+          <a:lstStyle/>
+          <a:p>
+            <a:pPr algn="l">
+              <a:lnSpc>
+                <a:spcPct val="110000"/>
+              </a:lnSpc>
+            </a:pPr>
+            <a:r>
+              <a:rPr sz="1100" b="0">
+                <a:solidFill>
+                  <a:srgbClr val="E0A23E"/>
+                </a:solidFill>
+                <a:latin typeface="Calibri"/>
+              </a:rPr>
+              <a:t>trade-off:  single-tenant ships now — keys already threaded, so it's config not a refactor</a:t>
+            </a:r>
+          </a:p>
+        </p:txBody>
+      </p:sp>
+      <p:sp>
+        <p:nvSpPr>
+          <p:cNvPr id="8" name="Rounded Rectangle 7"/>
+          <p:cNvSpPr/>
+          <p:nvPr/>
+        </p:nvSpPr>
+        <p:spPr>
+          <a:xfrm>
+            <a:off x="6172200" y="2148840"/>
+            <a:ext cx="5212080" cy="1828800"/>
+          </a:xfrm>
+          <a:prstGeom prst="roundRect">
+            <a:avLst/>
+          </a:prstGeom>
+          <a:solidFill>
+            <a:srgbClr val="F4F6F9"/>
+          </a:solidFill>
+          <a:ln w="12700">
+            <a:solidFill>
+              <a:srgbClr val="D7DEEA"/>
+            </a:solidFill>
+          </a:ln>
+          <a:effectLst/>
+        </p:spPr>
+        <p:style>
+          <a:lnRef idx="1">
+            <a:schemeClr val="accent1"/>
+          </a:lnRef>
+          <a:fillRef idx="3">
+            <a:schemeClr val="accent1"/>
+          </a:fillRef>
+          <a:effectRef idx="2">
+            <a:schemeClr val="accent1"/>
+          </a:effectRef>
+          <a:fontRef idx="minor">
+            <a:schemeClr val="lt1"/>
+          </a:fontRef>
+        </p:style>
+        <p:txBody>
+          <a:bodyPr rtlCol="0" anchor="ctr" wrap="square" lIns="73152" rIns="73152" tIns="36576" bIns="36576"/>
+          <a:lstStyle/>
+          <a:p>
+            <a:pPr algn="ctr"/>
+            <a:r>
+              <a:rPr sz="1200" b="1">
+                <a:solidFill>
+                  <a:srgbClr val="10151E"/>
+                </a:solidFill>
+                <a:latin typeface="Calibri"/>
+              </a:rPr>
+              <a:t/>
+            </a:r>
+          </a:p>
+        </p:txBody>
+      </p:sp>
+      <p:sp>
+        <p:nvSpPr>
+          <p:cNvPr id="9" name="TextBox 8"/>
+          <p:cNvSpPr txBox="1"/>
+          <p:nvPr/>
+        </p:nvSpPr>
+        <p:spPr>
+          <a:xfrm>
+            <a:off x="6446520" y="2331720"/>
+            <a:ext cx="4663440" cy="365760"/>
+          </a:xfrm>
+          <a:prstGeom prst="rect">
+            <a:avLst/>
+          </a:prstGeom>
+          <a:noFill/>
+        </p:spPr>
+        <p:txBody>
+          <a:bodyPr wrap="square" anchor="t" lIns="0" rIns="0" tIns="0" bIns="0">
+            <a:spAutoFit/>
+          </a:bodyPr>
+          <a:lstStyle/>
+          <a:p>
+            <a:pPr algn="l"/>
+            <a:r>
+              <a:rPr sz="1500" b="1">
+                <a:solidFill>
+                  <a:srgbClr val="10151E"/>
+                </a:solidFill>
+                <a:latin typeface="Trebuchet MS"/>
+              </a:rPr>
+              <a:t>Org dashboard</a:t>
+            </a:r>
+          </a:p>
+        </p:txBody>
+      </p:sp>
+      <p:sp>
+        <p:nvSpPr>
+          <p:cNvPr id="10" name="TextBox 9"/>
+          <p:cNvSpPr txBox="1"/>
+          <p:nvPr/>
+        </p:nvSpPr>
+        <p:spPr>
+          <a:xfrm>
+            <a:off x="6446520" y="2734056"/>
+            <a:ext cx="4663440" cy="640080"/>
+          </a:xfrm>
+          <a:prstGeom prst="rect">
+            <a:avLst/>
+          </a:prstGeom>
+          <a:noFill/>
+        </p:spPr>
+        <p:txBody>
+          <a:bodyPr wrap="square" anchor="t" lIns="0" rIns="0" tIns="0" bIns="0">
+            <a:spAutoFit/>
+          </a:bodyPr>
+          <a:lstStyle/>
+          <a:p>
+            <a:pPr algn="l">
+              <a:lnSpc>
+                <a:spcPct val="112000"/>
+              </a:lnSpc>
+            </a:pPr>
+            <a:r>
+              <a:rPr sz="1250" b="0">
+                <a:solidFill>
+                  <a:srgbClr val="475569"/>
+                </a:solidFill>
+                <a:latin typeface="Calibri"/>
+              </a:rPr>
+              <a:t>every generation → BigQuery → Looker (cost, groundedness, throughput)</a:t>
+            </a:r>
+          </a:p>
+        </p:txBody>
+      </p:sp>
+      <p:sp>
+        <p:nvSpPr>
+          <p:cNvPr id="11" name="TextBox 10"/>
+          <p:cNvSpPr txBox="1"/>
+          <p:nvPr/>
+        </p:nvSpPr>
+        <p:spPr>
+          <a:xfrm>
+            <a:off x="6446520" y="3447288"/>
+            <a:ext cx="4663440" cy="457200"/>
+          </a:xfrm>
+          <a:prstGeom prst="rect">
+            <a:avLst/>
+          </a:prstGeom>
+          <a:noFill/>
+        </p:spPr>
+        <p:txBody>
+          <a:bodyPr wrap="square" anchor="t" lIns="0" rIns="0" tIns="0" bIns="0">
+            <a:spAutoFit/>
+          </a:bodyPr>
+          <a:lstStyle/>
+          <a:p>
+            <a:pPr algn="l">
+              <a:lnSpc>
+                <a:spcPct val="110000"/>
+              </a:lnSpc>
+            </a:pPr>
+            <a:r>
+              <a:rPr sz="1100" b="0">
+                <a:solidFill>
+                  <a:srgbClr val="E0A23E"/>
+                </a:solidFill>
+                <a:latin typeface="Calibri"/>
+              </a:rPr>
+              <a:t>trade-off:  the BigQuery export is built — only the Looker wiring is left</a:t>
+            </a:r>
+          </a:p>
+        </p:txBody>
+      </p:sp>
+      <p:sp>
+        <p:nvSpPr>
+          <p:cNvPr id="12" name="Rounded Rectangle 11"/>
+          <p:cNvSpPr/>
+          <p:nvPr/>
+        </p:nvSpPr>
+        <p:spPr>
+          <a:xfrm>
+            <a:off x="777240" y="4114800"/>
+            <a:ext cx="5212080" cy="1828800"/>
+          </a:xfrm>
+          <a:prstGeom prst="roundRect">
+            <a:avLst/>
+          </a:prstGeom>
+          <a:solidFill>
+            <a:srgbClr val="F4F6F9"/>
+          </a:solidFill>
+          <a:ln w="12700">
+            <a:solidFill>
+              <a:srgbClr val="D7DEEA"/>
+            </a:solidFill>
+          </a:ln>
+          <a:effectLst/>
+        </p:spPr>
+        <p:style>
+          <a:lnRef idx="1">
+            <a:schemeClr val="accent1"/>
+          </a:lnRef>
+          <a:fillRef idx="3">
+            <a:schemeClr val="accent1"/>
+          </a:fillRef>
+          <a:effectRef idx="2">
+            <a:schemeClr val="accent1"/>
+          </a:effectRef>
+          <a:fontRef idx="minor">
+            <a:schemeClr val="lt1"/>
+          </a:fontRef>
+        </p:style>
+        <p:txBody>
+          <a:bodyPr rtlCol="0" anchor="ctr" wrap="square" lIns="73152" rIns="73152" tIns="36576" bIns="36576"/>
+          <a:lstStyle/>
+          <a:p>
+            <a:pPr algn="ctr"/>
+            <a:r>
+              <a:rPr sz="1200" b="1">
+                <a:solidFill>
+                  <a:srgbClr val="10151E"/>
+                </a:solidFill>
+                <a:latin typeface="Calibri"/>
+              </a:rPr>
+              <a:t/>
+            </a:r>
+          </a:p>
+        </p:txBody>
+      </p:sp>
+      <p:sp>
+        <p:nvSpPr>
+          <p:cNvPr id="13" name="TextBox 12"/>
+          <p:cNvSpPr txBox="1"/>
+          <p:nvPr/>
+        </p:nvSpPr>
+        <p:spPr>
+          <a:xfrm>
+            <a:off x="1051560" y="4297680"/>
+            <a:ext cx="4663440" cy="365760"/>
+          </a:xfrm>
+          <a:prstGeom prst="rect">
+            <a:avLst/>
+          </a:prstGeom>
+          <a:noFill/>
+        </p:spPr>
+        <p:txBody>
+          <a:bodyPr wrap="square" anchor="t" lIns="0" rIns="0" tIns="0" bIns="0">
+            <a:spAutoFit/>
+          </a:bodyPr>
+          <a:lstStyle/>
+          <a:p>
+            <a:pPr algn="l"/>
+            <a:r>
+              <a:rPr sz="1500" b="1">
+                <a:solidFill>
+                  <a:srgbClr val="10151E"/>
+                </a:solidFill>
+                <a:latin typeface="Trebuchet MS"/>
+              </a:rPr>
+              <a:t>Go agentic → Agent Engine</a:t>
+            </a:r>
+          </a:p>
+        </p:txBody>
+      </p:sp>
+      <p:sp>
+        <p:nvSpPr>
+          <p:cNvPr id="14" name="TextBox 13"/>
+          <p:cNvSpPr txBox="1"/>
+          <p:nvPr/>
+        </p:nvSpPr>
+        <p:spPr>
+          <a:xfrm>
+            <a:off x="1051560" y="4700016"/>
+            <a:ext cx="4663440" cy="640080"/>
+          </a:xfrm>
+          <a:prstGeom prst="rect">
+            <a:avLst/>
+          </a:prstGeom>
+          <a:noFill/>
+        </p:spPr>
+        <p:txBody>
+          <a:bodyPr wrap="square" anchor="t" lIns="0" rIns="0" tIns="0" bIns="0">
+            <a:spAutoFit/>
+          </a:bodyPr>
+          <a:lstStyle/>
+          <a:p>
+            <a:pPr algn="l">
+              <a:lnSpc>
+                <a:spcPct val="112000"/>
+              </a:lnSpc>
+            </a:pPr>
+            <a:r>
+              <a:rPr sz="1250" b="0">
+                <a:solidFill>
+                  <a:srgbClr val="475569"/>
+                </a:solidFill>
+                <a:latin typeface="Calibri"/>
+              </a:rPr>
+              <a:t>tools (live research, image sourcing) or a HITL pause</a:t>
+            </a:r>
+          </a:p>
+        </p:txBody>
+      </p:sp>
+      <p:sp>
+        <p:nvSpPr>
+          <p:cNvPr id="15" name="TextBox 14"/>
+          <p:cNvSpPr txBox="1"/>
+          <p:nvPr/>
+        </p:nvSpPr>
+        <p:spPr>
+          <a:xfrm>
+            <a:off x="1051560" y="5413248"/>
+            <a:ext cx="4663440" cy="457200"/>
+          </a:xfrm>
+          <a:prstGeom prst="rect">
+            <a:avLst/>
+          </a:prstGeom>
+          <a:noFill/>
+        </p:spPr>
+        <p:txBody>
+          <a:bodyPr wrap="square" anchor="t" lIns="0" rIns="0" tIns="0" bIns="0">
+            <a:spAutoFit/>
+          </a:bodyPr>
+          <a:lstStyle/>
+          <a:p>
+            <a:pPr algn="l">
+              <a:lnSpc>
+                <a:spcPct val="110000"/>
+              </a:lnSpc>
+            </a:pPr>
+            <a:r>
+              <a:rPr sz="1100" b="0">
+                <a:solidFill>
+                  <a:srgbClr val="E0A23E"/>
+                </a:solidFill>
+                <a:latin typeface="Calibri"/>
+              </a:rPr>
+              <a:t>trade-off:  agents add cost + opacity — not until there are real tools to call</a:t>
+            </a:r>
+          </a:p>
+        </p:txBody>
+      </p:sp>
+      <p:sp>
+        <p:nvSpPr>
+          <p:cNvPr id="16" name="Rounded Rectangle 15"/>
+          <p:cNvSpPr/>
+          <p:nvPr/>
+        </p:nvSpPr>
+        <p:spPr>
+          <a:xfrm>
+            <a:off x="6172200" y="4114800"/>
+            <a:ext cx="5212080" cy="1828800"/>
+          </a:xfrm>
+          <a:prstGeom prst="roundRect">
+            <a:avLst/>
+          </a:prstGeom>
+          <a:solidFill>
+            <a:srgbClr val="F4F6F9"/>
+          </a:solidFill>
+          <a:ln w="12700">
+            <a:solidFill>
+              <a:srgbClr val="D7DEEA"/>
+            </a:solidFill>
+          </a:ln>
+          <a:effectLst/>
+        </p:spPr>
+        <p:style>
+          <a:lnRef idx="1">
+            <a:schemeClr val="accent1"/>
+          </a:lnRef>
+          <a:fillRef idx="3">
+            <a:schemeClr val="accent1"/>
+          </a:fillRef>
+          <a:effectRef idx="2">
+            <a:schemeClr val="accent1"/>
+          </a:effectRef>
+          <a:fontRef idx="minor">
+            <a:schemeClr val="lt1"/>
+          </a:fontRef>
+        </p:style>
+        <p:txBody>
+          <a:bodyPr rtlCol="0" anchor="ctr" wrap="square" lIns="73152" rIns="73152" tIns="36576" bIns="36576"/>
+          <a:lstStyle/>
+          <a:p>
+            <a:pPr algn="ctr"/>
+            <a:r>
+              <a:rPr sz="1200" b="1">
+                <a:solidFill>
+                  <a:srgbClr val="10151E"/>
+                </a:solidFill>
+                <a:latin typeface="Calibri"/>
+              </a:rPr>
+              <a:t/>
+            </a:r>
+          </a:p>
+        </p:txBody>
+      </p:sp>
+      <p:sp>
+        <p:nvSpPr>
+          <p:cNvPr id="17" name="TextBox 16"/>
+          <p:cNvSpPr txBox="1"/>
+          <p:nvPr/>
+        </p:nvSpPr>
+        <p:spPr>
+          <a:xfrm>
+            <a:off x="6446520" y="4297680"/>
+            <a:ext cx="4663440" cy="365760"/>
+          </a:xfrm>
+          <a:prstGeom prst="rect">
+            <a:avLst/>
+          </a:prstGeom>
+          <a:noFill/>
+        </p:spPr>
+        <p:txBody>
+          <a:bodyPr wrap="square" anchor="t" lIns="0" rIns="0" tIns="0" bIns="0">
+            <a:spAutoFit/>
+          </a:bodyPr>
+          <a:lstStyle/>
+          <a:p>
+            <a:pPr algn="l"/>
+            <a:r>
+              <a:rPr sz="1500" b="1">
+                <a:solidFill>
+                  <a:srgbClr val="10151E"/>
+                </a:solidFill>
+                <a:latin typeface="Trebuchet MS"/>
+              </a:rPr>
+              <a:t>Harden</a:t>
+            </a:r>
+          </a:p>
+        </p:txBody>
+      </p:sp>
+      <p:sp>
+        <p:nvSpPr>
+          <p:cNvPr id="18" name="TextBox 17"/>
+          <p:cNvSpPr txBox="1"/>
+          <p:nvPr/>
+        </p:nvSpPr>
+        <p:spPr>
+          <a:xfrm>
+            <a:off x="6446520" y="4700016"/>
+            <a:ext cx="4663440" cy="640080"/>
+          </a:xfrm>
+          <a:prstGeom prst="rect">
+            <a:avLst/>
+          </a:prstGeom>
+          <a:noFill/>
+        </p:spPr>
+        <p:txBody>
+          <a:bodyPr wrap="square" anchor="t" lIns="0" rIns="0" tIns="0" bIns="0">
+            <a:spAutoFit/>
+          </a:bodyPr>
+          <a:lstStyle/>
+          <a:p>
+            <a:pPr algn="l">
+              <a:lnSpc>
+                <a:spcPct val="112000"/>
+              </a:lnSpc>
+            </a:pPr>
+            <a:r>
+              <a:rPr sz="1250" b="0">
+                <a:solidFill>
+                  <a:srgbClr val="475569"/>
+                </a:solidFill>
+                <a:latin typeface="Calibri"/>
+              </a:rPr>
+              <a:t>tune the faithfulness judge · golden eval set in CI</a:t>
+            </a:r>
+          </a:p>
+        </p:txBody>
+      </p:sp>
+      <p:sp>
+        <p:nvSpPr>
+          <p:cNvPr id="19" name="TextBox 18"/>
+          <p:cNvSpPr txBox="1"/>
+          <p:nvPr/>
+        </p:nvSpPr>
+        <p:spPr>
+          <a:xfrm>
+            <a:off x="6446520" y="5413248"/>
+            <a:ext cx="4663440" cy="457200"/>
+          </a:xfrm>
+          <a:prstGeom prst="rect">
+            <a:avLst/>
+          </a:prstGeom>
+          <a:noFill/>
+        </p:spPr>
+        <p:txBody>
+          <a:bodyPr wrap="square" anchor="t" lIns="0" rIns="0" tIns="0" bIns="0">
+            <a:spAutoFit/>
+          </a:bodyPr>
+          <a:lstStyle/>
+          <a:p>
+            <a:pPr algn="l">
+              <a:lnSpc>
+                <a:spcPct val="110000"/>
+              </a:lnSpc>
+            </a:pPr>
+            <a:r>
+              <a:rPr sz="1100" b="0">
+                <a:solidFill>
+                  <a:srgbClr val="E0A23E"/>
+                </a:solidFill>
+                <a:latin typeface="Calibri"/>
+              </a:rPr>
+              <a:t>trade-off:  model calls use the global endpoint today — EU residency is the open gap</a:t>
+            </a:r>
+          </a:p>
+        </p:txBody>
+      </p:sp>
+      <p:sp>
+        <p:nvSpPr>
+          <p:cNvPr id="20" name="TextBox 19"/>
+          <p:cNvSpPr txBox="1"/>
+          <p:nvPr/>
+        </p:nvSpPr>
+        <p:spPr>
+          <a:xfrm>
+            <a:off x="777240" y="6473952"/>
+            <a:ext cx="9144000" cy="274320"/>
+          </a:xfrm>
+          <a:prstGeom prst="rect">
+            <a:avLst/>
+          </a:prstGeom>
+          <a:noFill/>
+        </p:spPr>
+        <p:txBody>
+          <a:bodyPr wrap="square" anchor="t" lIns="0" rIns="0" tIns="0" bIns="0">
+            <a:spAutoFit/>
+          </a:bodyPr>
+          <a:lstStyle/>
+          <a:p>
+            <a:pPr algn="l"/>
+            <a:r>
+              <a:rPr sz="900" b="0">
+                <a:solidFill>
+                  <a:srgbClr val="64748B"/>
+                </a:solidFill>
+                <a:latin typeface="Consolas"/>
+              </a:rPr>
+              <a:t>ML6 — Senior AI Engineer Challenge  ·  Case 2 · GenAI collateral</a:t>
+            </a:r>
+          </a:p>
+        </p:txBody>
+      </p:sp>
+      <p:sp>
+        <p:nvSpPr>
+          <p:cNvPr id="21" name="TextBox 20"/>
+          <p:cNvSpPr txBox="1"/>
+          <p:nvPr/>
+        </p:nvSpPr>
+        <p:spPr>
+          <a:xfrm>
+            <a:off x="11338560" y="6473952"/>
+            <a:ext cx="457200" cy="274320"/>
+          </a:xfrm>
+          <a:prstGeom prst="rect">
+            <a:avLst/>
+          </a:prstGeom>
+          <a:noFill/>
+        </p:spPr>
+        <p:txBody>
+          <a:bodyPr wrap="square" anchor="t" lIns="0" rIns="0" tIns="0" bIns="0">
+            <a:spAutoFit/>
+          </a:bodyPr>
+          <a:lstStyle/>
+          <a:p>
+            <a:pPr algn="r"/>
+            <a:r>
+              <a:rPr sz="900" b="0">
+                <a:solidFill>
+                  <a:srgbClr val="64748B"/>
+                </a:solidFill>
+                <a:latin typeface="Consolas"/>
+              </a:rPr>
+              <a:t>11</a:t>
             </a:r>
           </a:p>
         </p:txBody>
@@ -5207,7 +6194,7 @@
                 </a:solidFill>
                 <a:latin typeface="Consolas"/>
               </a:rPr>
-              <a:t>POST /generate  →  202 + job_id  (poll)</a:t>
+              <a:t>POST /generate  →  200  ArticleJSON (sync)</a:t>
             </a:r>
           </a:p>
         </p:txBody>
@@ -7349,14 +8336,60 @@
       </p:cxnSp>
       <p:sp>
         <p:nvSpPr>
-          <p:cNvPr id="16" name="TextBox 15"/>
+          <p:cNvPr id="16" name="Rounded Rectangle 15"/>
+          <p:cNvSpPr/>
+          <p:nvPr/>
+        </p:nvSpPr>
+        <p:spPr>
+          <a:xfrm>
+            <a:off x="777240" y="3246120"/>
+            <a:ext cx="2697480" cy="1554480"/>
+          </a:xfrm>
+          <a:prstGeom prst="roundRect">
+            <a:avLst/>
+          </a:prstGeom>
+          <a:solidFill>
+            <a:srgbClr val="1B2230"/>
+          </a:solidFill>
+          <a:ln w="25400">
+            <a:solidFill>
+              <a:srgbClr val="E0A23E"/>
+            </a:solidFill>
+          </a:ln>
+          <a:effectLst/>
+        </p:spPr>
+        <p:style>
+          <a:lnRef idx="1">
+            <a:schemeClr val="accent1"/>
+          </a:lnRef>
+          <a:fillRef idx="3">
+            <a:schemeClr val="accent1"/>
+          </a:fillRef>
+          <a:effectRef idx="2">
+            <a:schemeClr val="accent1"/>
+          </a:effectRef>
+          <a:fontRef idx="minor">
+            <a:schemeClr val="lt1"/>
+          </a:fontRef>
+        </p:style>
+        <p:txBody>
+          <a:bodyPr rtlCol="0" anchor="ctr"/>
+          <a:lstStyle/>
+          <a:p>
+            <a:pPr algn="ctr"/>
+          </a:p>
+        </p:txBody>
+      </p:sp>
+      <p:sp>
+        <p:nvSpPr>
+          <p:cNvPr id="17" name="TextBox 16"/>
           <p:cNvSpPr txBox="1"/>
           <p:nvPr/>
         </p:nvSpPr>
         <p:spPr>
           <a:xfrm>
-            <a:off x="777240" y="5440680"/>
-            <a:ext cx="10607040" cy="548640"/>
+            <a:off x="987552" y="3401568"/>
+            <a:ext cx="2377440" cy="274320"/>
           </a:xfrm>
           <a:prstGeom prst="rect">
             <a:avLst/>
@@ -7369,33 +8402,29 @@
           </a:bodyPr>
           <a:lstStyle/>
           <a:p>
-            <a:pPr algn="l">
-              <a:lnSpc>
-                <a:spcPct val="120000"/>
-              </a:lnSpc>
-            </a:pPr>
-            <a:r>
-              <a:rPr sz="1200" b="0">
-                <a:solidFill>
-                  <a:srgbClr val="7E8CA0"/>
+            <a:pPr algn="l"/>
+            <a:r>
+              <a:rPr sz="1100" b="1" spc="260">
+                <a:solidFill>
+                  <a:srgbClr val="E0A23E"/>
                 </a:solidFill>
                 <a:latin typeface="Consolas"/>
               </a:rPr>
-              <a:t>Cross-cutting:  Google ID-token auth + IAM   ·   Model Armor   ·   per-tenant CMEK   ·   EU residency   ·   Pub/Sub DLQ   ·   Terraform (infra/)</a:t>
-            </a:r>
-          </a:p>
-        </p:txBody>
-      </p:sp>
-      <p:sp>
-        <p:nvSpPr>
-          <p:cNvPr id="17" name="TextBox 16"/>
+              <a:t>WHY CLOUD RUN</a:t>
+            </a:r>
+          </a:p>
+        </p:txBody>
+      </p:sp>
+      <p:sp>
+        <p:nvSpPr>
+          <p:cNvPr id="18" name="TextBox 17"/>
           <p:cNvSpPr txBox="1"/>
           <p:nvPr/>
         </p:nvSpPr>
         <p:spPr>
           <a:xfrm>
-            <a:off x="777240" y="6473952"/>
-            <a:ext cx="9144000" cy="274320"/>
+            <a:off x="987552" y="3730752"/>
+            <a:ext cx="2331720" cy="1005840"/>
           </a:xfrm>
           <a:prstGeom prst="rect">
             <a:avLst/>
@@ -7408,8 +8437,477 @@
           </a:bodyPr>
           <a:lstStyle/>
           <a:p>
+            <a:pPr algn="l">
+              <a:lnSpc>
+                <a:spcPct val="116000"/>
+              </a:lnSpc>
+            </a:pPr>
+            <a:r>
+              <a:rPr sz="1150" b="0">
+                <a:solidFill>
+                  <a:srgbClr val="C7D0DE"/>
+                </a:solidFill>
+                <a:latin typeface="Calibri"/>
+              </a:rPr>
+              <a:t>Deterministic + tool-less → one stateless service. No agent runtime, no servers — scale-to-zero, tiny blast radius.</a:t>
+            </a:r>
+          </a:p>
+        </p:txBody>
+      </p:sp>
+      <p:cxnSp>
+        <p:nvCxnSpPr>
+          <p:cNvPr id="19" name="Connector 18"/>
+          <p:cNvCxnSpPr/>
+          <p:nvPr/>
+        </p:nvCxnSpPr>
+        <p:spPr>
+          <a:xfrm flipV="1">
+            <a:off x="2240280" y="2578608"/>
+            <a:ext cx="1463040" cy="667512"/>
+          </a:xfrm>
+          <a:prstGeom prst="line">
+            <a:avLst/>
+          </a:prstGeom>
+          <a:ln w="25400">
+            <a:solidFill>
+              <a:srgbClr val="E0A23E"/>
+            </a:solidFill>
+            <a:tailEnd type="triangle" w="med" len="med"/>
+          </a:ln>
+        </p:spPr>
+        <p:style>
+          <a:lnRef idx="2">
+            <a:schemeClr val="accent1"/>
+          </a:lnRef>
+          <a:fillRef idx="0">
+            <a:schemeClr val="accent1"/>
+          </a:fillRef>
+          <a:effectRef idx="1">
+            <a:schemeClr val="accent1"/>
+          </a:effectRef>
+          <a:fontRef idx="minor">
+            <a:schemeClr val="tx1"/>
+          </a:fontRef>
+        </p:style>
+      </p:cxnSp>
+      <p:sp>
+        <p:nvSpPr>
+          <p:cNvPr id="20" name="Rounded Rectangle 19"/>
+          <p:cNvSpPr/>
+          <p:nvPr/>
+        </p:nvSpPr>
+        <p:spPr>
+          <a:xfrm>
+            <a:off x="8778240" y="2852928"/>
+            <a:ext cx="2651760" cy="676656"/>
+          </a:xfrm>
+          <a:prstGeom prst="roundRect">
+            <a:avLst/>
+          </a:prstGeom>
+          <a:solidFill>
+            <a:srgbClr val="1B2230"/>
+          </a:solidFill>
+          <a:ln w="19050">
+            <a:solidFill>
+              <a:srgbClr val="E0A23E"/>
+            </a:solidFill>
+          </a:ln>
+          <a:effectLst/>
+        </p:spPr>
+        <p:style>
+          <a:lnRef idx="1">
+            <a:schemeClr val="accent1"/>
+          </a:lnRef>
+          <a:fillRef idx="3">
+            <a:schemeClr val="accent1"/>
+          </a:fillRef>
+          <a:effectRef idx="2">
+            <a:schemeClr val="accent1"/>
+          </a:effectRef>
+          <a:fontRef idx="minor">
+            <a:schemeClr val="lt1"/>
+          </a:fontRef>
+        </p:style>
+        <p:txBody>
+          <a:bodyPr rtlCol="0" anchor="ctr"/>
+          <a:lstStyle/>
+          <a:p>
+            <a:pPr algn="ctr"/>
+          </a:p>
+        </p:txBody>
+      </p:sp>
+      <p:sp>
+        <p:nvSpPr>
+          <p:cNvPr id="21" name="TextBox 20"/>
+          <p:cNvSpPr txBox="1"/>
+          <p:nvPr/>
+        </p:nvSpPr>
+        <p:spPr>
+          <a:xfrm>
+            <a:off x="8979408" y="2944368"/>
+            <a:ext cx="2377440" cy="256032"/>
+          </a:xfrm>
+          <a:prstGeom prst="rect">
+            <a:avLst/>
+          </a:prstGeom>
+          <a:noFill/>
+        </p:spPr>
+        <p:txBody>
+          <a:bodyPr wrap="square" anchor="t" lIns="0" rIns="0" tIns="0" bIns="0">
+            <a:spAutoFit/>
+          </a:bodyPr>
+          <a:lstStyle/>
+          <a:p>
             <a:pPr algn="l"/>
             <a:r>
+              <a:rPr sz="1000" b="1" spc="260">
+                <a:solidFill>
+                  <a:srgbClr val="E0A23E"/>
+                </a:solidFill>
+                <a:latin typeface="Consolas"/>
+              </a:rPr>
+              <a:t>NO API KEY</a:t>
+            </a:r>
+          </a:p>
+        </p:txBody>
+      </p:sp>
+      <p:sp>
+        <p:nvSpPr>
+          <p:cNvPr id="22" name="TextBox 21"/>
+          <p:cNvSpPr txBox="1"/>
+          <p:nvPr/>
+        </p:nvSpPr>
+        <p:spPr>
+          <a:xfrm>
+            <a:off x="8979408" y="3200400"/>
+            <a:ext cx="2286000" cy="292608"/>
+          </a:xfrm>
+          <a:prstGeom prst="rect">
+            <a:avLst/>
+          </a:prstGeom>
+          <a:noFill/>
+        </p:spPr>
+        <p:txBody>
+          <a:bodyPr wrap="square" anchor="t" lIns="0" rIns="0" tIns="0" bIns="0">
+            <a:spAutoFit/>
+          </a:bodyPr>
+          <a:lstStyle/>
+          <a:p>
+            <a:pPr algn="l">
+              <a:lnSpc>
+                <a:spcPct val="105000"/>
+              </a:lnSpc>
+            </a:pPr>
+            <a:r>
+              <a:rPr sz="1000" b="0">
+                <a:solidFill>
+                  <a:srgbClr val="C7D0DE"/>
+                </a:solidFill>
+                <a:latin typeface="Calibri"/>
+              </a:rPr>
+              <a:t>Vertex via the Cloud Run service account (ADC)</a:t>
+            </a:r>
+          </a:p>
+        </p:txBody>
+      </p:sp>
+      <p:sp>
+        <p:nvSpPr>
+          <p:cNvPr id="23" name="Rounded Rectangle 22"/>
+          <p:cNvSpPr/>
+          <p:nvPr/>
+        </p:nvSpPr>
+        <p:spPr>
+          <a:xfrm>
+            <a:off x="8778240" y="3639312"/>
+            <a:ext cx="2651760" cy="960120"/>
+          </a:xfrm>
+          <a:prstGeom prst="roundRect">
+            <a:avLst/>
+          </a:prstGeom>
+          <a:solidFill>
+            <a:srgbClr val="1B2230"/>
+          </a:solidFill>
+          <a:ln w="19050">
+            <a:solidFill>
+              <a:srgbClr val="E0A23E"/>
+            </a:solidFill>
+          </a:ln>
+          <a:effectLst/>
+        </p:spPr>
+        <p:style>
+          <a:lnRef idx="1">
+            <a:schemeClr val="accent1"/>
+          </a:lnRef>
+          <a:fillRef idx="3">
+            <a:schemeClr val="accent1"/>
+          </a:fillRef>
+          <a:effectRef idx="2">
+            <a:schemeClr val="accent1"/>
+          </a:effectRef>
+          <a:fontRef idx="minor">
+            <a:schemeClr val="lt1"/>
+          </a:fontRef>
+        </p:style>
+        <p:txBody>
+          <a:bodyPr rtlCol="0" anchor="ctr"/>
+          <a:lstStyle/>
+          <a:p>
+            <a:pPr algn="ctr"/>
+          </a:p>
+        </p:txBody>
+      </p:sp>
+      <p:sp>
+        <p:nvSpPr>
+          <p:cNvPr id="24" name="TextBox 23"/>
+          <p:cNvSpPr txBox="1"/>
+          <p:nvPr/>
+        </p:nvSpPr>
+        <p:spPr>
+          <a:xfrm>
+            <a:off x="8979408" y="3730752"/>
+            <a:ext cx="2377440" cy="256032"/>
+          </a:xfrm>
+          <a:prstGeom prst="rect">
+            <a:avLst/>
+          </a:prstGeom>
+          <a:noFill/>
+        </p:spPr>
+        <p:txBody>
+          <a:bodyPr wrap="square" anchor="t" lIns="0" rIns="0" tIns="0" bIns="0">
+            <a:spAutoFit/>
+          </a:bodyPr>
+          <a:lstStyle/>
+          <a:p>
+            <a:pPr algn="l"/>
+            <a:r>
+              <a:rPr sz="1000" b="1" spc="260">
+                <a:solidFill>
+                  <a:srgbClr val="E0A23E"/>
+                </a:solidFill>
+                <a:latin typeface="Consolas"/>
+              </a:rPr>
+              <a:t>ASYNC PARSE</a:t>
+            </a:r>
+          </a:p>
+        </p:txBody>
+      </p:sp>
+      <p:sp>
+        <p:nvSpPr>
+          <p:cNvPr id="25" name="TextBox 24"/>
+          <p:cNvSpPr txBox="1"/>
+          <p:nvPr/>
+        </p:nvSpPr>
+        <p:spPr>
+          <a:xfrm>
+            <a:off x="8979408" y="4005072"/>
+            <a:ext cx="2331720" cy="548640"/>
+          </a:xfrm>
+          <a:prstGeom prst="rect">
+            <a:avLst/>
+          </a:prstGeom>
+          <a:noFill/>
+        </p:spPr>
+        <p:txBody>
+          <a:bodyPr wrap="square" anchor="t" lIns="0" rIns="0" tIns="0" bIns="0">
+            <a:spAutoFit/>
+          </a:bodyPr>
+          <a:lstStyle/>
+          <a:p>
+            <a:pPr algn="l">
+              <a:lnSpc>
+                <a:spcPct val="112000"/>
+              </a:lnSpc>
+            </a:pPr>
+            <a:r>
+              <a:rPr sz="1000" b="0">
+                <a:solidFill>
+                  <a:srgbClr val="C7D0DE"/>
+                </a:solidFill>
+                <a:latin typeface="Calibri"/>
+              </a:rPr>
+              <a:t>Pub/Sub queues parse/upload bursts (+ DLQ), off the request path.</a:t>
+            </a:r>
+          </a:p>
+        </p:txBody>
+      </p:sp>
+      <p:cxnSp>
+        <p:nvCxnSpPr>
+          <p:cNvPr id="26" name="Connector 25"/>
+          <p:cNvCxnSpPr/>
+          <p:nvPr/>
+        </p:nvCxnSpPr>
+        <p:spPr>
+          <a:xfrm flipH="1" flipV="1">
+            <a:off x="8430768" y="3584448"/>
+            <a:ext cx="329184" cy="393191"/>
+          </a:xfrm>
+          <a:prstGeom prst="line">
+            <a:avLst/>
+          </a:prstGeom>
+          <a:ln w="19050">
+            <a:solidFill>
+              <a:srgbClr val="E0A23E"/>
+            </a:solidFill>
+            <a:tailEnd type="triangle" w="med" len="med"/>
+          </a:ln>
+        </p:spPr>
+        <p:style>
+          <a:lnRef idx="2">
+            <a:schemeClr val="accent1"/>
+          </a:lnRef>
+          <a:fillRef idx="0">
+            <a:schemeClr val="accent1"/>
+          </a:fillRef>
+          <a:effectRef idx="1">
+            <a:schemeClr val="accent1"/>
+          </a:effectRef>
+          <a:fontRef idx="minor">
+            <a:schemeClr val="tx1"/>
+          </a:fontRef>
+        </p:style>
+      </p:cxnSp>
+      <p:sp>
+        <p:nvSpPr>
+          <p:cNvPr id="27" name="Rounded Rectangle 26"/>
+          <p:cNvSpPr/>
+          <p:nvPr/>
+        </p:nvSpPr>
+        <p:spPr>
+          <a:xfrm>
+            <a:off x="713232" y="5321808"/>
+            <a:ext cx="10744200" cy="786384"/>
+          </a:xfrm>
+          <a:prstGeom prst="roundRect">
+            <a:avLst/>
+          </a:prstGeom>
+          <a:noFill/>
+          <a:ln w="15875">
+            <a:solidFill>
+              <a:srgbClr val="E0A23E"/>
+            </a:solidFill>
+          </a:ln>
+          <a:effectLst/>
+        </p:spPr>
+        <p:style>
+          <a:lnRef idx="1">
+            <a:schemeClr val="accent1"/>
+          </a:lnRef>
+          <a:fillRef idx="3">
+            <a:schemeClr val="accent1"/>
+          </a:fillRef>
+          <a:effectRef idx="2">
+            <a:schemeClr val="accent1"/>
+          </a:effectRef>
+          <a:fontRef idx="minor">
+            <a:schemeClr val="lt1"/>
+          </a:fontRef>
+        </p:style>
+        <p:txBody>
+          <a:bodyPr rtlCol="0" anchor="ctr"/>
+          <a:lstStyle/>
+          <a:p>
+            <a:pPr algn="ctr"/>
+          </a:p>
+        </p:txBody>
+      </p:sp>
+      <p:sp>
+        <p:nvSpPr>
+          <p:cNvPr id="28" name="TextBox 27"/>
+          <p:cNvSpPr txBox="1"/>
+          <p:nvPr/>
+        </p:nvSpPr>
+        <p:spPr>
+          <a:xfrm>
+            <a:off x="914400" y="5413248"/>
+            <a:ext cx="2743200" cy="274320"/>
+          </a:xfrm>
+          <a:prstGeom prst="rect">
+            <a:avLst/>
+          </a:prstGeom>
+          <a:noFill/>
+        </p:spPr>
+        <p:txBody>
+          <a:bodyPr wrap="square" anchor="t" lIns="0" rIns="0" tIns="0" bIns="0">
+            <a:spAutoFit/>
+          </a:bodyPr>
+          <a:lstStyle/>
+          <a:p>
+            <a:pPr algn="l"/>
+            <a:r>
+              <a:rPr sz="1000" b="1" spc="260">
+                <a:solidFill>
+                  <a:srgbClr val="E0A23E"/>
+                </a:solidFill>
+                <a:latin typeface="Consolas"/>
+              </a:rPr>
+              <a:t>SECURITY SPINE</a:t>
+            </a:r>
+          </a:p>
+        </p:txBody>
+      </p:sp>
+      <p:sp>
+        <p:nvSpPr>
+          <p:cNvPr id="29" name="TextBox 28"/>
+          <p:cNvSpPr txBox="1"/>
+          <p:nvPr/>
+        </p:nvSpPr>
+        <p:spPr>
+          <a:xfrm>
+            <a:off x="914400" y="5724144"/>
+            <a:ext cx="10469880" cy="457200"/>
+          </a:xfrm>
+          <a:prstGeom prst="rect">
+            <a:avLst/>
+          </a:prstGeom>
+          <a:noFill/>
+        </p:spPr>
+        <p:txBody>
+          <a:bodyPr wrap="square" anchor="t" lIns="0" rIns="0" tIns="0" bIns="0">
+            <a:spAutoFit/>
+          </a:bodyPr>
+          <a:lstStyle/>
+          <a:p>
+            <a:pPr algn="l">
+              <a:lnSpc>
+                <a:spcPct val="112000"/>
+              </a:lnSpc>
+            </a:pPr>
+            <a:r>
+              <a:rPr sz="1100" b="0">
+                <a:solidFill>
+                  <a:srgbClr val="9FB0C8"/>
+                </a:solidFill>
+                <a:latin typeface="Consolas"/>
+              </a:rPr>
+              <a:t>Google ID-token auth + IAM   ·   Model Armor   ·   per-tenant CMEK   ·   EU residency   ·   Pub/Sub DLQ   ·   Terraform (infra/)</a:t>
+            </a:r>
+          </a:p>
+        </p:txBody>
+      </p:sp>
+      <p:sp>
+        <p:nvSpPr>
+          <p:cNvPr id="30" name="TextBox 29"/>
+          <p:cNvSpPr txBox="1"/>
+          <p:nvPr/>
+        </p:nvSpPr>
+        <p:spPr>
+          <a:xfrm>
+            <a:off x="777240" y="6473952"/>
+            <a:ext cx="9144000" cy="274320"/>
+          </a:xfrm>
+          <a:prstGeom prst="rect">
+            <a:avLst/>
+          </a:prstGeom>
+          <a:noFill/>
+        </p:spPr>
+        <p:txBody>
+          <a:bodyPr wrap="square" anchor="t" lIns="0" rIns="0" tIns="0" bIns="0">
+            <a:spAutoFit/>
+          </a:bodyPr>
+          <a:lstStyle/>
+          <a:p>
+            <a:pPr algn="l"/>
+            <a:r>
               <a:rPr sz="900" b="0">
                 <a:solidFill>
                   <a:srgbClr val="5A6B82"/>
@@ -7423,7 +8921,7 @@
       </p:sp>
       <p:sp>
         <p:nvSpPr>
-          <p:cNvPr id="18" name="TextBox 17"/>
+          <p:cNvPr id="31" name="TextBox 30"/>
           <p:cNvSpPr txBox="1"/>
           <p:nvPr/>
         </p:nvSpPr>
@@ -9323,7 +10821,7 @@
                 </a:solidFill>
                 <a:latin typeface="Calibri"/>
               </a:rPr>
-              <a:t>•  /generate returns 202 — never blocks</a:t>
+              <a:t>•  long/bursty jobs → ?async=true (off-path)</a:t>
             </a:r>
           </a:p>
           <a:p>
@@ -9718,23 +11216,7 @@
                 </a:solidFill>
                 <a:latin typeface="Consolas"/>
               </a:rPr>
-              <a:t>    → 202  {"job_id":"…"}</a:t>
-            </a:r>
-          </a:p>
-          <a:p>
-            <a:pPr algn="l">
-              <a:lnSpc>
-                <a:spcPct val="125000"/>
-              </a:lnSpc>
-            </a:pPr>
-            <a:r>
-              <a:rPr sz="1100" b="0">
-                <a:solidFill>
-                  <a:srgbClr val="9FE8DF"/>
-                </a:solidFill>
-                <a:latin typeface="Consolas"/>
-              </a:rPr>
-              <a:t>$ curl $URL/generate/demo/&lt;job_id&gt;   → { status: done, result: {…} }</a:t>
+              <a:t>    → 200  { template_id, blocks:[…], confidence, meta:{…} }</a:t>
             </a:r>
           </a:p>
         </p:txBody>

</xml_diff>